<commit_message>
Finalize docs and submission artifacts
</commit_message>
<xml_diff>
--- a/presentation.pptx
+++ b/presentation.pptx
@@ -3113,7 +3113,7 @@
           <a:lstStyle/>
           <a:p>
             <a:r>
-              <a:t>Word Game — Microservices with Docker &amp; Low‑Code UI</a:t>
+              <a:t>Word Game — Microservices με Docker Compose και Appsmith</a:t>
             </a:r>
           </a:p>
         </p:txBody>
@@ -3134,12 +3134,17 @@
           <a:lstStyle/>
           <a:p>
             <a:r>
-              <a:t>Assignment deliverables • 2025-12-26</a:t>
-            </a:r>
-          </a:p>
-          <a:p>
-            <a:r>
-              <a:t>Student(s): ______________________________</a:t>
+              <a:t>Απαλλακτική εργασία 2025–2026</a:t>
+            </a:r>
+          </a:p>
+          <a:p>
+            <a:r>
+              <a:t>Student(s): ____________________</a:t>
+            </a:r>
+          </a:p>
+          <a:p>
+            <a:r>
+              <a:t>Date: 2025-12-27</a:t>
             </a:r>
           </a:p>
         </p:txBody>
@@ -3178,7 +3183,7 @@
           <a:lstStyle/>
           <a:p>
             <a:r>
-              <a:t>Screenshot — Adminer Tables</a:t>
+              <a:t>Screenshot — Adminer tables</a:t>
             </a:r>
           </a:p>
         </p:txBody>
@@ -3191,12 +3196,20 @@
         </p:nvSpPr>
         <p:spPr>
           <a:xfrm>
-            <a:off x="640080" y="1463040"/>
-            <a:ext cx="7315200" cy="4389120"/>
+            <a:off x="731520" y="1554480"/>
+            <a:ext cx="10789920" cy="4389120"/>
           </a:xfrm>
           <a:prstGeom prst="rect">
             <a:avLst/>
           </a:prstGeom>
+          <a:solidFill>
+            <a:srgbClr val="F5F5F5"/>
+          </a:solidFill>
+          <a:ln w="25400">
+            <a:solidFill>
+              <a:srgbClr val="828282"/>
+            </a:solidFill>
+          </a:ln>
         </p:spPr>
         <p:style>
           <a:lnRef idx="1">
@@ -3216,11 +3229,19 @@
           <a:bodyPr rtlCol="0" anchor="ctr"/>
           <a:lstStyle/>
           <a:p>
-            <a:pPr>
-              <a:defRPr sz="1800"/>
+            <a:pPr algn="ctr">
+              <a:defRPr sz="2000" b="1"/>
             </a:pPr>
             <a:r>
-              <a:t>INSERT SCREENSHOT: Adminer showing favorites + api_logs rows</a:t>
+              <a:t>INSERT SCREENSHOT</a:t>
+            </a:r>
+          </a:p>
+          <a:p>
+            <a:pPr algn="ctr">
+              <a:defRPr sz="1400"/>
+            </a:pPr>
+            <a:r>
+              <a:t>Show: game_sessions + guesses + api_logs populated after using the UI</a:t>
             </a:r>
           </a:p>
         </p:txBody>
@@ -3259,7 +3280,7 @@
           <a:lstStyle/>
           <a:p>
             <a:r>
-              <a:t>Exercise Requirements (summary)</a:t>
+              <a:t>Exercise requirements (per apalaktiki_ntinos.pdf)</a:t>
             </a:r>
           </a:p>
         </p:txBody>
@@ -3281,31 +3302,37 @@
           <a:p>
             <a:pPr/>
             <a:r>
-              <a:t>Docker Compose with 5 containers started together</a:t>
+              <a:t>Docker Compose orchestration (required containers start together)</a:t>
             </a:r>
           </a:p>
           <a:p>
             <a:pPr/>
             <a:r>
-              <a:t>Appsmith (or Tooljet/Budibase) as UI</a:t>
+              <a:t>Low‑code UI: Appsmith</a:t>
             </a:r>
           </a:p>
           <a:p>
             <a:pPr/>
             <a:r>
-              <a:t>Local DB (≥2 tables) + DB admin tool (Adminer/phpMyAdmin)</a:t>
+              <a:t>Local DB (&gt;=2 tables) + DB admin tool (Adminer)</a:t>
             </a:r>
           </a:p>
           <a:p>
             <a:pPr/>
             <a:r>
-              <a:t>Two Mock REST APIs: (1) svenwal/jsonplaceholder, (2) custom Dockerfile image</a:t>
+              <a:t>Two mock REST APIs: (1) svenwal/jsonplaceholder, (2) custom Dockerfile image</a:t>
             </a:r>
           </a:p>
           <a:p>
             <a:pPr/>
             <a:r>
-              <a:t>Integration with an external serverless DB or API</a:t>
+              <a:t>External serverless DB or API integration + logging/persistence</a:t>
+            </a:r>
+          </a:p>
+          <a:p>
+            <a:pPr/>
+            <a:r>
+              <a:t>Report (PDF) + Presentation (PPT) with run instructions and screenshots</a:t>
             </a:r>
           </a:p>
         </p:txBody>
@@ -3344,7 +3371,7 @@
           <a:lstStyle/>
           <a:p>
             <a:r>
-              <a:t>Architecture (5 containers)</a:t>
+              <a:t>Architecture (services)</a:t>
             </a:r>
           </a:p>
         </p:txBody>
@@ -3366,31 +3393,37 @@
           <a:p>
             <a:pPr/>
             <a:r>
-              <a:t>Appsmith UI (http://localhost)</a:t>
+              <a:t>appsmith (UI) — http://localhost</a:t>
             </a:r>
           </a:p>
           <a:p>
             <a:pPr/>
             <a:r>
-              <a:t>PostgreSQL DB (favorites, api_logs)</a:t>
+              <a:t>postgres (DB) — tables: game_sessions, guesses, leaderboard, api_logs, favorites</a:t>
             </a:r>
           </a:p>
           <a:p>
             <a:pPr/>
             <a:r>
-              <a:t>Adminer (http://localhost:8080)</a:t>
+              <a:t>adminer (DB admin) — http://localhost:8080</a:t>
             </a:r>
           </a:p>
           <a:p>
             <a:pPr/>
             <a:r>
-              <a:t>Mock API 1: jsonplaceholder seeded via volume (http://localhost:3000)</a:t>
+              <a:t>mock-api-1 (wordpacks) — http://localhost:3000/wordpacks</a:t>
             </a:r>
           </a:p>
           <a:p>
             <a:pPr/>
             <a:r>
-              <a:t>Mock API 2: custom json-server image (http://localhost:3001)</a:t>
+              <a:t>mock-api-2 (hints catalog) — http://localhost:3001/hints</a:t>
+            </a:r>
+          </a:p>
+          <a:p>
+            <a:pPr/>
+            <a:r>
+              <a:t>backend (FastAPI game service) — internal: http://backend:8000 (not exposed to host)</a:t>
             </a:r>
           </a:p>
         </p:txBody>
@@ -3429,7 +3462,7 @@
           <a:lstStyle/>
           <a:p>
             <a:r>
-              <a:t>External Serverless Integration</a:t>
+              <a:t>Integrations used in gameplay</a:t>
             </a:r>
           </a:p>
         </p:txBody>
@@ -3451,19 +3484,25 @@
           <a:p>
             <a:pPr/>
             <a:r>
-              <a:t>dictionaryapi.dev (public dictionary API)</a:t>
+              <a:t>Mock API 1 provides wordpacks (user selects pack → affects target word selection).</a:t>
             </a:r>
           </a:p>
           <a:p>
             <a:pPr/>
             <a:r>
-              <a:t>UI performs lookup and stores logs in api_logs table</a:t>
+              <a:t>Mock API 2 provides hint types (user selects hint type → affects Get hint behavior).</a:t>
             </a:r>
           </a:p>
           <a:p>
             <a:pPr/>
             <a:r>
-              <a:t>No API key required</a:t>
+              <a:t>External serverless API provides random words when no pack is selected.</a:t>
+            </a:r>
+          </a:p>
+          <a:p>
+            <a:pPr/>
+            <a:r>
+              <a:t>External API calls are stored in Postgres (api_logs) to prove integration.</a:t>
             </a:r>
           </a:p>
         </p:txBody>
@@ -3502,7 +3541,7 @@
           <a:lstStyle/>
           <a:p>
             <a:r>
-              <a:t>UI Flow (Appsmith)</a:t>
+              <a:t>UI flow (Appsmith)</a:t>
             </a:r>
           </a:p>
         </p:txBody>
@@ -3524,19 +3563,19 @@
           <a:p>
             <a:pPr/>
             <a:r>
-              <a:t>Load/Refresh: fetch wordpacks and powerups from mock APIs</a:t>
+              <a:t>Gameplay tab: Start new game → Submit guess → Get hint → Reveal word (end game).</a:t>
             </a:r>
           </a:p>
           <a:p>
             <a:pPr/>
             <a:r>
-              <a:t>Select row → Save to Favorites (stored in PostgreSQL)</a:t>
+              <a:t>Integrations &amp; Logs tab: choose wordpack + hint type, then inspect DB log tables.</a:t>
             </a:r>
           </a:p>
           <a:p>
             <a:pPr/>
             <a:r>
-              <a:t>Lookup word definition via dictionary API → Save request/response to api_logs</a:t>
+              <a:t>Leaderboard refreshes after a game ends (win or reveal).</a:t>
             </a:r>
           </a:p>
         </p:txBody>
@@ -3575,39 +3614,367 @@
           <a:lstStyle/>
           <a:p>
             <a:r>
-              <a:t>DB Tables Used</a:t>
-            </a:r>
-          </a:p>
-        </p:txBody>
-      </p:sp>
-      <p:sp>
-        <p:nvSpPr>
-          <p:cNvPr id="3" name="Content Placeholder 2"/>
-          <p:cNvSpPr>
-            <a:spLocks noGrp="1"/>
-          </p:cNvSpPr>
-          <p:nvPr>
-            <p:ph idx="1"/>
-          </p:nvPr>
-        </p:nvSpPr>
-        <p:spPr/>
-        <p:txBody>
-          <a:bodyPr/>
-          <a:lstStyle/>
-          <a:p>
-            <a:pPr/>
-            <a:r>
-              <a:t>favorites: stores selected items (wordpacks/powerups) as JSONB</a:t>
-            </a:r>
-          </a:p>
-          <a:p>
-            <a:pPr/>
-            <a:r>
-              <a:t>api_logs: stores external API calls and responses (JSONB)</a:t>
-            </a:r>
-          </a:p>
-        </p:txBody>
-      </p:sp>
+              <a:t>Compose services (from compose.yaml)</a:t>
+            </a:r>
+          </a:p>
+        </p:txBody>
+      </p:sp>
+      <p:graphicFrame>
+        <p:nvGraphicFramePr>
+          <p:cNvPr id="3" name="Table 2"/>
+          <p:cNvGraphicFramePr>
+            <a:graphicFrameLocks noGrp="1"/>
+          </p:cNvGraphicFramePr>
+          <p:nvPr/>
+        </p:nvGraphicFramePr>
+        <p:xfrm>
+          <a:off x="548640" y="1371600"/>
+          <a:ext cx="11155680" cy="4389120"/>
+        </p:xfrm>
+        <a:graphic>
+          <a:graphicData uri="http://schemas.openxmlformats.org/drawingml/2006/table">
+            <a:tbl>
+              <a:tblPr firstRow="1" bandRow="1">
+                <a:tableStyleId>{5C22544A-7EE6-4342-B048-85BDC9FD1C3A}</a:tableStyleId>
+              </a:tblPr>
+              <a:tblGrid>
+                <a:gridCol w="3718560"/>
+                <a:gridCol w="3718560"/>
+                <a:gridCol w="3718560"/>
+              </a:tblGrid>
+              <a:tr h="627017">
+                <a:tc>
+                  <a:txBody>
+                    <a:bodyPr/>
+                    <a:lstStyle/>
+                    <a:p>
+                      <a:pPr>
+                        <a:defRPr b="1" sz="1200"/>
+                      </a:pPr>
+                      <a:r>
+                        <a:t>Service</a:t>
+                      </a:r>
+                    </a:p>
+                  </a:txBody>
+                  <a:tcPr/>
+                </a:tc>
+                <a:tc>
+                  <a:txBody>
+                    <a:bodyPr/>
+                    <a:lstStyle/>
+                    <a:p>
+                      <a:pPr>
+                        <a:defRPr b="1" sz="1200"/>
+                      </a:pPr>
+                      <a:r>
+                        <a:t>Image / build</a:t>
+                      </a:r>
+                    </a:p>
+                  </a:txBody>
+                  <a:tcPr/>
+                </a:tc>
+                <a:tc>
+                  <a:txBody>
+                    <a:bodyPr/>
+                    <a:lstStyle/>
+                    <a:p>
+                      <a:pPr>
+                        <a:defRPr b="1" sz="1200"/>
+                      </a:pPr>
+                      <a:r>
+                        <a:t>Ports</a:t>
+                      </a:r>
+                    </a:p>
+                  </a:txBody>
+                  <a:tcPr/>
+                </a:tc>
+              </a:tr>
+              <a:tr h="627017">
+                <a:tc>
+                  <a:txBody>
+                    <a:bodyPr/>
+                    <a:lstStyle/>
+                    <a:p>
+                      <a:pPr>
+                        <a:defRPr sz="1100"/>
+                      </a:pPr>
+                      <a:r>
+                        <a:t>adminer</a:t>
+                      </a:r>
+                    </a:p>
+                  </a:txBody>
+                  <a:tcPr/>
+                </a:tc>
+                <a:tc>
+                  <a:txBody>
+                    <a:bodyPr/>
+                    <a:lstStyle/>
+                    <a:p>
+                      <a:pPr>
+                        <a:defRPr sz="1100"/>
+                      </a:pPr>
+                      <a:r>
+                        <a:t>adminer:latest</a:t>
+                      </a:r>
+                    </a:p>
+                  </a:txBody>
+                  <a:tcPr/>
+                </a:tc>
+                <a:tc>
+                  <a:txBody>
+                    <a:bodyPr/>
+                    <a:lstStyle/>
+                    <a:p>
+                      <a:pPr>
+                        <a:defRPr sz="1100"/>
+                      </a:pPr>
+                      <a:r>
+                        <a:t>8080:8080</a:t>
+                      </a:r>
+                    </a:p>
+                  </a:txBody>
+                  <a:tcPr/>
+                </a:tc>
+              </a:tr>
+              <a:tr h="627017">
+                <a:tc>
+                  <a:txBody>
+                    <a:bodyPr/>
+                    <a:lstStyle/>
+                    <a:p>
+                      <a:pPr>
+                        <a:defRPr sz="1100"/>
+                      </a:pPr>
+                      <a:r>
+                        <a:t>appsmith</a:t>
+                      </a:r>
+                    </a:p>
+                  </a:txBody>
+                  <a:tcPr/>
+                </a:tc>
+                <a:tc>
+                  <a:txBody>
+                    <a:bodyPr/>
+                    <a:lstStyle/>
+                    <a:p>
+                      <a:pPr>
+                        <a:defRPr sz="1100"/>
+                      </a:pPr>
+                      <a:r>
+                        <a:t>appsmith/appsmith-ce:latest</a:t>
+                      </a:r>
+                    </a:p>
+                  </a:txBody>
+                  <a:tcPr/>
+                </a:tc>
+                <a:tc>
+                  <a:txBody>
+                    <a:bodyPr/>
+                    <a:lstStyle/>
+                    <a:p>
+                      <a:pPr>
+                        <a:defRPr sz="1100"/>
+                      </a:pPr>
+                      <a:r>
+                        <a:t>80:80</a:t>
+                      </a:r>
+                    </a:p>
+                  </a:txBody>
+                  <a:tcPr/>
+                </a:tc>
+              </a:tr>
+              <a:tr h="627017">
+                <a:tc>
+                  <a:txBody>
+                    <a:bodyPr/>
+                    <a:lstStyle/>
+                    <a:p>
+                      <a:pPr>
+                        <a:defRPr sz="1100"/>
+                      </a:pPr>
+                      <a:r>
+                        <a:t>backend</a:t>
+                      </a:r>
+                    </a:p>
+                  </a:txBody>
+                  <a:tcPr/>
+                </a:tc>
+                <a:tc>
+                  <a:txBody>
+                    <a:bodyPr/>
+                    <a:lstStyle/>
+                    <a:p>
+                      <a:pPr>
+                        <a:defRPr sz="1100"/>
+                      </a:pPr>
+                      <a:r>
+                        <a:t>build: ./backend (Dockerfile)</a:t>
+                      </a:r>
+                    </a:p>
+                  </a:txBody>
+                  <a:tcPr/>
+                </a:tc>
+                <a:tc>
+                  <a:txBody>
+                    <a:bodyPr/>
+                    <a:lstStyle/>
+                    <a:p>
+                      <a:pPr>
+                        <a:defRPr sz="1100"/>
+                      </a:pPr>
+                      <a:r>
+                        <a:t>(not published)</a:t>
+                      </a:r>
+                    </a:p>
+                  </a:txBody>
+                  <a:tcPr/>
+                </a:tc>
+              </a:tr>
+              <a:tr h="627017">
+                <a:tc>
+                  <a:txBody>
+                    <a:bodyPr/>
+                    <a:lstStyle/>
+                    <a:p>
+                      <a:pPr>
+                        <a:defRPr sz="1100"/>
+                      </a:pPr>
+                      <a:r>
+                        <a:t>mock-api-1</a:t>
+                      </a:r>
+                    </a:p>
+                  </a:txBody>
+                  <a:tcPr/>
+                </a:tc>
+                <a:tc>
+                  <a:txBody>
+                    <a:bodyPr/>
+                    <a:lstStyle/>
+                    <a:p>
+                      <a:pPr>
+                        <a:defRPr sz="1100"/>
+                      </a:pPr>
+                      <a:r>
+                        <a:t>svenwal/jsonplaceholder:latest</a:t>
+                      </a:r>
+                    </a:p>
+                  </a:txBody>
+                  <a:tcPr/>
+                </a:tc>
+                <a:tc>
+                  <a:txBody>
+                    <a:bodyPr/>
+                    <a:lstStyle/>
+                    <a:p>
+                      <a:pPr>
+                        <a:defRPr sz="1100"/>
+                      </a:pPr>
+                      <a:r>
+                        <a:t>3000:3000</a:t>
+                      </a:r>
+                    </a:p>
+                  </a:txBody>
+                  <a:tcPr/>
+                </a:tc>
+              </a:tr>
+              <a:tr h="627017">
+                <a:tc>
+                  <a:txBody>
+                    <a:bodyPr/>
+                    <a:lstStyle/>
+                    <a:p>
+                      <a:pPr>
+                        <a:defRPr sz="1100"/>
+                      </a:pPr>
+                      <a:r>
+                        <a:t>mock-api-2</a:t>
+                      </a:r>
+                    </a:p>
+                  </a:txBody>
+                  <a:tcPr/>
+                </a:tc>
+                <a:tc>
+                  <a:txBody>
+                    <a:bodyPr/>
+                    <a:lstStyle/>
+                    <a:p>
+                      <a:pPr>
+                        <a:defRPr sz="1100"/>
+                      </a:pPr>
+                      <a:r>
+                        <a:t>build: ./rest-apis/mock-api-2 (Dockerfile)</a:t>
+                      </a:r>
+                    </a:p>
+                  </a:txBody>
+                  <a:tcPr/>
+                </a:tc>
+                <a:tc>
+                  <a:txBody>
+                    <a:bodyPr/>
+                    <a:lstStyle/>
+                    <a:p>
+                      <a:pPr>
+                        <a:defRPr sz="1100"/>
+                      </a:pPr>
+                      <a:r>
+                        <a:t>3001:3001</a:t>
+                      </a:r>
+                    </a:p>
+                  </a:txBody>
+                  <a:tcPr/>
+                </a:tc>
+              </a:tr>
+              <a:tr h="627018">
+                <a:tc>
+                  <a:txBody>
+                    <a:bodyPr/>
+                    <a:lstStyle/>
+                    <a:p>
+                      <a:pPr>
+                        <a:defRPr sz="1100"/>
+                      </a:pPr>
+                      <a:r>
+                        <a:t>postgres</a:t>
+                      </a:r>
+                    </a:p>
+                  </a:txBody>
+                  <a:tcPr/>
+                </a:tc>
+                <a:tc>
+                  <a:txBody>
+                    <a:bodyPr/>
+                    <a:lstStyle/>
+                    <a:p>
+                      <a:pPr>
+                        <a:defRPr sz="1100"/>
+                      </a:pPr>
+                      <a:r>
+                        <a:t>postgres:15-alpine</a:t>
+                      </a:r>
+                    </a:p>
+                  </a:txBody>
+                  <a:tcPr/>
+                </a:tc>
+                <a:tc>
+                  <a:txBody>
+                    <a:bodyPr/>
+                    <a:lstStyle/>
+                    <a:p>
+                      <a:pPr>
+                        <a:defRPr sz="1100"/>
+                      </a:pPr>
+                      <a:r>
+                        <a:t>5432:5432</a:t>
+                      </a:r>
+                    </a:p>
+                  </a:txBody>
+                  <a:tcPr/>
+                </a:tc>
+              </a:tr>
+            </a:tbl>
+          </a:graphicData>
+        </a:graphic>
+      </p:graphicFrame>
     </p:spTree>
   </p:cSld>
   <p:clrMapOvr>
@@ -3642,7 +4009,7 @@
           <a:lstStyle/>
           <a:p>
             <a:r>
-              <a:t>Run Instructions</a:t>
+              <a:t>Run instructions (quick)</a:t>
             </a:r>
           </a:p>
         </p:txBody>
@@ -3670,13 +4037,25 @@
           <a:p>
             <a:pPr/>
             <a:r>
-              <a:t>Open Appsmith: http://localhost and import appsmith/word-game-app.json</a:t>
+              <a:t>Open Appsmith: http://localhost</a:t>
             </a:r>
           </a:p>
           <a:p>
             <a:pPr/>
             <a:r>
-              <a:t>Open Adminer: http://localhost:8080 (server: postgres, db: wordgame)</a:t>
+              <a:t>Import: appsmith/word-game-app.json</a:t>
+            </a:r>
+          </a:p>
+          <a:p>
+            <a:pPr/>
+            <a:r>
+              <a:t>Reconnect datasources: WordGameDB (postgres), MockAPI1, MockAPI2, GameAPI (backend), ServerlessAPI</a:t>
+            </a:r>
+          </a:p>
+          <a:p>
+            <a:pPr/>
+            <a:r>
+              <a:t>Open Adminer: http://localhost:8080 and verify tables (game_sessions, guesses, api_logs).</a:t>
             </a:r>
           </a:p>
         </p:txBody>
@@ -3728,12 +4107,20 @@
         </p:nvSpPr>
         <p:spPr>
           <a:xfrm>
-            <a:off x="640080" y="1463040"/>
-            <a:ext cx="7315200" cy="4389120"/>
+            <a:off x="731520" y="1554480"/>
+            <a:ext cx="10789920" cy="4389120"/>
           </a:xfrm>
           <a:prstGeom prst="rect">
             <a:avLst/>
           </a:prstGeom>
+          <a:solidFill>
+            <a:srgbClr val="F5F5F5"/>
+          </a:solidFill>
+          <a:ln w="25400">
+            <a:solidFill>
+              <a:srgbClr val="828282"/>
+            </a:solidFill>
+          </a:ln>
         </p:spPr>
         <p:style>
           <a:lnRef idx="1">
@@ -3753,16 +4140,19 @@
           <a:bodyPr rtlCol="0" anchor="ctr"/>
           <a:lstStyle/>
           <a:p>
-            <a:pPr>
-              <a:defRPr sz="1800"/>
+            <a:pPr algn="ctr">
+              <a:defRPr sz="2000" b="1"/>
             </a:pPr>
             <a:r>
-              <a:t>INSERT SCREENSHOT: docker compose -f compose.yaml ps</a:t>
-            </a:r>
-          </a:p>
-          <a:p>
-            <a:r>
-              <a:t>(showing 5 running containers)</a:t>
+              <a:t>INSERT SCREENSHOT</a:t>
+            </a:r>
+          </a:p>
+          <a:p>
+            <a:pPr algn="ctr">
+              <a:defRPr sz="1400"/>
+            </a:pPr>
+            <a:r>
+              <a:t>Show: docker compose -f compose.yaml ps (all services Up)</a:t>
             </a:r>
           </a:p>
         </p:txBody>
@@ -3801,7 +4191,7 @@
           <a:lstStyle/>
           <a:p>
             <a:r>
-              <a:t>Screenshot — Appsmith Dashboard</a:t>
+              <a:t>Screenshot — Appsmith Gameplay</a:t>
             </a:r>
           </a:p>
         </p:txBody>
@@ -3814,12 +4204,20 @@
         </p:nvSpPr>
         <p:spPr>
           <a:xfrm>
-            <a:off x="640080" y="1463040"/>
-            <a:ext cx="7315200" cy="4389120"/>
+            <a:off x="731520" y="1554480"/>
+            <a:ext cx="10789920" cy="4389120"/>
           </a:xfrm>
           <a:prstGeom prst="rect">
             <a:avLst/>
           </a:prstGeom>
+          <a:solidFill>
+            <a:srgbClr val="F5F5F5"/>
+          </a:solidFill>
+          <a:ln w="25400">
+            <a:solidFill>
+              <a:srgbClr val="828282"/>
+            </a:solidFill>
+          </a:ln>
         </p:spPr>
         <p:style>
           <a:lnRef idx="1">
@@ -3839,11 +4237,19 @@
           <a:bodyPr rtlCol="0" anchor="ctr"/>
           <a:lstStyle/>
           <a:p>
-            <a:pPr>
-              <a:defRPr sz="1800"/>
+            <a:pPr algn="ctr">
+              <a:defRPr sz="2000" b="1"/>
             </a:pPr>
             <a:r>
-              <a:t>INSERT SCREENSHOT: Appsmith UI with loaded tables + favorites updates</a:t>
+              <a:t>INSERT SCREENSHOT</a:t>
+            </a:r>
+          </a:p>
+          <a:p>
+            <a:pPr algn="ctr">
+              <a:defRPr sz="1400"/>
+            </a:pPr>
+            <a:r>
+              <a:t>Show: Start new game + guesses + hints + leaderboard (working UI)</a:t>
             </a:r>
           </a:p>
         </p:txBody>

</xml_diff>